<commit_message>
slides: repaint all figures + deck to Spring TAC theme palette
Pulled accent colors directly from theme3.xml of the Spring TAC pptx:
  navy    #0E2841 (dk2)      headlines, diagram frames
  teal    #156082 (accent1)  Mexican-like cohort / WGS / EAS
  orange  #E97132 (accent2)  Brazilian-like cohort / AFR / LAI highlight
  forest  #196B24 (accent3)  EUR
  cyan    #0F9ED5 (accent4)  SAS
  plum    #A02B93 (accent5)  AMR

Also on fig_wgs_panels: concise single-line bold x-labels (no parens),
percent bar labels (92%, 94%), removed dotted baseline lines.

Co-Authored-By: Claude Opus 4.7 (1M context) <noreply@anthropic.com>
Claude-Session: https://claude.ai/code/session_01Fbouf9yKVWMvU7uqqi6hid
</commit_message>
<xml_diff>
--- a/slides/thesis_committee_slides.pptx
+++ b/slides/thesis_committee_slides.pptx
@@ -3878,7 +3878,7 @@
             <a:avLst/>
           </a:prstGeom>
           <a:solidFill>
-            <a:srgbClr val="C94A53"/>
+            <a:srgbClr val="E97132"/>
           </a:solidFill>
           <a:ln>
             <a:noFill/>
@@ -3932,7 +3932,7 @@
             <a:r>
               <a:rPr sz="3000" i="0" b="1">
                 <a:solidFill>
-                  <a:srgbClr val="1F3A5F"/>
+                  <a:srgbClr val="0E2841"/>
                 </a:solidFill>
               </a:rPr>
               <a:t>Building an ancestry-informed genotype-preprocessing pipeline</a:t>
@@ -3943,7 +3943,7 @@
             <a:r>
               <a:rPr sz="3000" i="0" b="1">
                 <a:solidFill>
-                  <a:srgbClr val="1F3A5F"/>
+                  <a:srgbClr val="0E2841"/>
                 </a:solidFill>
               </a:rPr>
               <a:t>and benchmarking local ancestry inference for Latino cohorts</a:t>
@@ -4141,7 +4141,7 @@
             <a:r>
               <a:rPr sz="2400" b="1">
                 <a:solidFill>
-                  <a:srgbClr val="1F3A5F"/>
+                  <a:srgbClr val="0E2841"/>
                 </a:solidFill>
               </a:rPr>
               <a:t>Public Amerindigenous references are ~7× smaller than other continents.</a:t>
@@ -4352,7 +4352,7 @@
             <a:r>
               <a:rPr sz="2400" b="1">
                 <a:solidFill>
-                  <a:srgbClr val="1F3A5F"/>
+                  <a:srgbClr val="0E2841"/>
                 </a:solidFill>
               </a:rPr>
               <a:t>We simulated admixed cohorts to measure per-hap LAI recall.</a:t>
@@ -4375,7 +4375,7 @@
             <a:avLst/>
           </a:prstGeom>
           <a:solidFill>
-            <a:srgbClr val="EEE9E0"/>
+            <a:srgbClr val="E8E8E8"/>
           </a:solidFill>
           <a:ln w="6350">
             <a:solidFill>
@@ -4405,7 +4405,7 @@
             <a:r>
               <a:rPr sz="1300" b="1">
                 <a:solidFill>
-                  <a:srgbClr val="1F3A5F"/>
+                  <a:srgbClr val="0E2841"/>
                 </a:solidFill>
               </a:rPr>
               <a:t>Reference haps</a:t>
@@ -4500,7 +4500,7 @@
             <a:avLst/>
           </a:prstGeom>
           <a:solidFill>
-            <a:srgbClr val="EEE9E0"/>
+            <a:srgbClr val="E8E8E8"/>
           </a:solidFill>
           <a:ln w="6350">
             <a:solidFill>
@@ -4530,7 +4530,7 @@
             <a:r>
               <a:rPr sz="1300" b="1">
                 <a:solidFill>
-                  <a:srgbClr val="1F3A5F"/>
+                  <a:srgbClr val="0E2841"/>
                 </a:solidFill>
               </a:rPr>
               <a:t>Phasing</a:t>
@@ -4616,7 +4616,7 @@
             <a:avLst/>
           </a:prstGeom>
           <a:solidFill>
-            <a:srgbClr val="EEE9E0"/>
+            <a:srgbClr val="E8E8E8"/>
           </a:solidFill>
           <a:ln w="6350">
             <a:solidFill>
@@ -4646,7 +4646,7 @@
             <a:r>
               <a:rPr sz="1300" b="1">
                 <a:solidFill>
-                  <a:srgbClr val="1F3A5F"/>
+                  <a:srgbClr val="0E2841"/>
                 </a:solidFill>
               </a:rPr>
               <a:t>Simulate admixed</a:t>
@@ -4741,7 +4741,7 @@
             <a:avLst/>
           </a:prstGeom>
           <a:solidFill>
-            <a:srgbClr val="EEE9E0"/>
+            <a:srgbClr val="E8E8E8"/>
           </a:solidFill>
           <a:ln w="6350">
             <a:solidFill>
@@ -4771,7 +4771,7 @@
             <a:r>
               <a:rPr sz="1300" b="1">
                 <a:solidFill>
-                  <a:srgbClr val="1F3A5F"/>
+                  <a:srgbClr val="0E2841"/>
                 </a:solidFill>
               </a:rPr>
               <a:t>Local ancestry</a:t>
@@ -4857,7 +4857,7 @@
             <a:avLst/>
           </a:prstGeom>
           <a:solidFill>
-            <a:srgbClr val="EEE9E0"/>
+            <a:srgbClr val="E8E8E8"/>
           </a:solidFill>
           <a:ln w="6350">
             <a:solidFill>
@@ -4887,7 +4887,7 @@
             <a:r>
               <a:rPr sz="1300" b="1">
                 <a:solidFill>
-                  <a:srgbClr val="1F3A5F"/>
+                  <a:srgbClr val="0E2841"/>
                 </a:solidFill>
               </a:rPr>
               <a:t>Score</a:t>
@@ -4950,7 +4950,7 @@
             <a:r>
               <a:rPr sz="1300" i="0" b="1">
                 <a:solidFill>
-                  <a:srgbClr val="1F3A5F"/>
+                  <a:srgbClr val="0E2841"/>
                 </a:solidFill>
               </a:rPr>
               <a:t>Six reference-panel combinations tested</a:t>
@@ -4973,7 +4973,7 @@
             <a:avLst/>
           </a:prstGeom>
           <a:solidFill>
-            <a:srgbClr val="EEE9E0"/>
+            <a:srgbClr val="E8E8E8"/>
           </a:solidFill>
           <a:ln w="17780">
             <a:solidFill>
@@ -5037,11 +5037,11 @@
             <a:avLst/>
           </a:prstGeom>
           <a:solidFill>
-            <a:srgbClr val="EEE9E0"/>
+            <a:srgbClr val="E8E8E8"/>
           </a:solidFill>
           <a:ln w="17780">
             <a:solidFill>
-              <a:srgbClr val="C94A53"/>
+              <a:srgbClr val="E97132"/>
             </a:solidFill>
           </a:ln>
         </p:spPr>
@@ -5067,7 +5067,7 @@
             <a:r>
               <a:rPr sz="1100" b="1">
                 <a:solidFill>
-                  <a:srgbClr val="C94A53"/>
+                  <a:srgbClr val="E97132"/>
                 </a:solidFill>
               </a:rPr>
               <a:t>NAT_HGDPMXB</a:t>
@@ -5101,11 +5101,11 @@
             <a:avLst/>
           </a:prstGeom>
           <a:solidFill>
-            <a:srgbClr val="EEE9E0"/>
+            <a:srgbClr val="E8E8E8"/>
           </a:solidFill>
           <a:ln w="17780">
             <a:solidFill>
-              <a:srgbClr val="C94A53"/>
+              <a:srgbClr val="E97132"/>
             </a:solidFill>
           </a:ln>
         </p:spPr>
@@ -5131,7 +5131,7 @@
             <a:r>
               <a:rPr sz="1100" b="1">
                 <a:solidFill>
-                  <a:srgbClr val="C94A53"/>
+                  <a:srgbClr val="E97132"/>
                 </a:solidFill>
               </a:rPr>
               <a:t>NAT_HGDPMXB_FULL</a:t>
@@ -5165,11 +5165,11 @@
             <a:avLst/>
           </a:prstGeom>
           <a:solidFill>
-            <a:srgbClr val="EEE9E0"/>
+            <a:srgbClr val="E8E8E8"/>
           </a:solidFill>
           <a:ln w="17780">
             <a:solidFill>
-              <a:srgbClr val="3E6BB0"/>
+              <a:srgbClr val="156082"/>
             </a:solidFill>
           </a:ln>
         </p:spPr>
@@ -5195,7 +5195,7 @@
             <a:r>
               <a:rPr sz="1100" b="1">
                 <a:solidFill>
-                  <a:srgbClr val="3E6BB0"/>
+                  <a:srgbClr val="156082"/>
                 </a:solidFill>
               </a:rPr>
               <a:t>NAT_HOMOG</a:t>
@@ -5229,11 +5229,11 @@
             <a:avLst/>
           </a:prstGeom>
           <a:solidFill>
-            <a:srgbClr val="EEE9E0"/>
+            <a:srgbClr val="E8E8E8"/>
           </a:solidFill>
           <a:ln w="17780">
             <a:solidFill>
-              <a:srgbClr val="4C9F70"/>
+              <a:srgbClr val="196B24"/>
             </a:solidFill>
           </a:ln>
         </p:spPr>
@@ -5259,7 +5259,7 @@
             <a:r>
               <a:rPr sz="1100" b="1">
                 <a:solidFill>
-                  <a:srgbClr val="4C9F70"/>
+                  <a:srgbClr val="196B24"/>
                 </a:solidFill>
               </a:rPr>
               <a:t>NAT_PEL</a:t>
@@ -5293,11 +5293,11 @@
             <a:avLst/>
           </a:prstGeom>
           <a:solidFill>
-            <a:srgbClr val="EEE9E0"/>
+            <a:srgbClr val="E8E8E8"/>
           </a:solidFill>
           <a:ln w="17780">
             <a:solidFill>
-              <a:srgbClr val="4C9F70"/>
+              <a:srgbClr val="196B24"/>
             </a:solidFill>
           </a:ln>
         </p:spPr>
@@ -5323,7 +5323,7 @@
             <a:r>
               <a:rPr sz="1100" b="1">
                 <a:solidFill>
-                  <a:srgbClr val="4C9F70"/>
+                  <a:srgbClr val="196B24"/>
                 </a:solidFill>
               </a:rPr>
               <a:t>NAT_PEL_EAS</a:t>
@@ -5368,7 +5368,7 @@
             <a:r>
               <a:rPr sz="1300" i="0" b="1">
                 <a:solidFill>
-                  <a:srgbClr val="1F3A5F"/>
+                  <a:srgbClr val="0E2841"/>
                 </a:solidFill>
               </a:rPr>
               <a:t>Two simulated admixed cohorts</a:t>
@@ -5554,7 +5554,7 @@
             <a:r>
               <a:rPr sz="2400" b="1">
                 <a:solidFill>
-                  <a:srgbClr val="1F3A5F"/>
+                  <a:srgbClr val="0E2841"/>
                 </a:solidFill>
               </a:rPr>
               <a:t>Best reference panel depends on the target cohort's composition.</a:t>
@@ -5613,7 +5613,7 @@
         <p:spPr>
           <a:xfrm>
             <a:off x="502920" y="1508760"/>
-            <a:ext cx="7498079" cy="3862647"/>
+            <a:ext cx="7498079" cy="3599078"/>
           </a:xfrm>
           <a:prstGeom prst="rect">
             <a:avLst/>
@@ -5646,7 +5646,7 @@
             <a:r>
               <a:rPr sz="1300" i="0" b="1">
                 <a:solidFill>
-                  <a:srgbClr val="1F3A5F"/>
+                  <a:srgbClr val="0E2841"/>
                 </a:solidFill>
               </a:rPr>
               <a:t>Takeaways</a:t>
@@ -5915,7 +5915,7 @@
             <a:r>
               <a:rPr sz="2400" b="1">
                 <a:solidFill>
-                  <a:srgbClr val="1F3A5F"/>
+                  <a:srgbClr val="0E2841"/>
                 </a:solidFill>
               </a:rPr>
               <a:t>Chip-density LAI holds within ~1% of WGS on a Mexican-like cohort.</a:t>
@@ -6007,7 +6007,7 @@
             <a:r>
               <a:rPr sz="1300" i="0" b="1">
                 <a:solidFill>
-                  <a:srgbClr val="1F3A5F"/>
+                  <a:srgbClr val="0E2841"/>
                 </a:solidFill>
               </a:rPr>
               <a:t>Implications for GWAS</a:t>
@@ -6290,7 +6290,7 @@
             <a:r>
               <a:rPr sz="2400" b="1">
                 <a:solidFill>
-                  <a:srgbClr val="1F3A5F"/>
+                  <a:srgbClr val="0E2841"/>
                 </a:solidFill>
               </a:rPr>
               <a:t>8-module Nextflow preprocessing pipeline built; benchmarking underway.</a:t>
@@ -6382,7 +6382,7 @@
             <a:r>
               <a:rPr sz="1300" i="0" b="1">
                 <a:solidFill>
-                  <a:srgbClr val="1F3A5F"/>
+                  <a:srgbClr val="0E2841"/>
                 </a:solidFill>
               </a:rPr>
               <a:t>Status since Spring TAC</a:t>
@@ -6405,7 +6405,7 @@
             <a:avLst/>
           </a:prstGeom>
           <a:solidFill>
-            <a:srgbClr val="4C9F70"/>
+            <a:srgbClr val="196B24"/>
           </a:solidFill>
           <a:ln>
             <a:noFill/>
@@ -6490,7 +6490,7 @@
             <a:avLst/>
           </a:prstGeom>
           <a:solidFill>
-            <a:srgbClr val="4C9F70"/>
+            <a:srgbClr val="196B24"/>
           </a:solidFill>
           <a:ln>
             <a:noFill/>
@@ -6575,7 +6575,7 @@
             <a:avLst/>
           </a:prstGeom>
           <a:solidFill>
-            <a:srgbClr val="3E6BB0"/>
+            <a:srgbClr val="156082"/>
           </a:solidFill>
           <a:ln>
             <a:noFill/>
@@ -6660,7 +6660,7 @@
             <a:avLst/>
           </a:prstGeom>
           <a:solidFill>
-            <a:srgbClr val="3E6BB0"/>
+            <a:srgbClr val="156082"/>
           </a:solidFill>
           <a:ln>
             <a:noFill/>
@@ -6745,7 +6745,7 @@
             <a:avLst/>
           </a:prstGeom>
           <a:solidFill>
-            <a:srgbClr val="C94A53"/>
+            <a:srgbClr val="E97132"/>
           </a:solidFill>
           <a:ln>
             <a:noFill/>

</xml_diff>

<commit_message>
slides: retitle and reorder figures per committee feedback
- fig_wgs_all_ancestry: subplots alphabetical (AFR, AMR, EUR); title
  "Local Ancestry Inference: Amerindigenous Ancestry vs. European
  and African"
- fig_chip_vs_wgs: bold centered title "LAI Accuracy: Genotyping
  (unimputed) vs. Whole-genome sequencing"; legend under plot with
  bold labels; y-label bold + labelpad
- fig_amr_disparity: AMR bars corrected (38 pre-MXB / 88 post-MXB);
  plot title replaced with "Available Homogeneous Sample Counts in
  1KG-HGDP-MXB"; slide-2 caption updated to 88

Co-Authored-By: Claude Opus 4.7 (1M context) <noreply@anthropic.com>
Claude-Session: https://claude.ai/code/session_01Fbouf9yKVWMvU7uqqi6hid
</commit_message>
<xml_diff>
--- a/slides/thesis_committee_slides.pptx
+++ b/slides/thesis_committee_slides.pptx
@@ -4200,7 +4200,7 @@
         <p:spPr>
           <a:xfrm>
             <a:off x="365760" y="1508760"/>
-            <a:ext cx="11430000" cy="4321954"/>
+            <a:ext cx="11430000" cy="4392192"/>
           </a:xfrm>
           <a:prstGeom prst="rect">
             <a:avLst/>
@@ -4236,7 +4236,7 @@
                   <a:srgbClr val="1A1A1A"/>
                 </a:solidFill>
               </a:rPr>
-              <a:t>Adding 50 MX Biobank WGS samples raises AMR to 138 haps — still leaves Central America, Southern Cone, Amazon, Caribbean underrepresented.</a:t>
+              <a:t>Adding 50 MX Biobank WGS samples brings AMR to 88 — still leaves Central America, Southern Cone, Amazon, Caribbean underrepresented.</a:t>
             </a:r>
           </a:p>
         </p:txBody>
@@ -5974,7 +5974,7 @@
         <p:spPr>
           <a:xfrm>
             <a:off x="502920" y="1508760"/>
-            <a:ext cx="7680960" cy="3457667"/>
+            <a:ext cx="7680960" cy="3609547"/>
           </a:xfrm>
           <a:prstGeom prst="rect">
             <a:avLst/>

</xml_diff>

<commit_message>
slides: add 3-ancestry overview as slide 4, deck now 7 slides
Order:
  1. Title
  2. Motivation (AMR reference disparity)
  3. Methods
  4. NEW - 3-ancestry overview (AFR/AMR/EUR side-by-side)
  5. AMR zoom (6 panels x 2 tracks)
  6. Chip vs WGS robustness
  7. Preprocessing pipeline update

The new slide 4 establishes that AMR is the ancestry where panel
choice actually matters, motivating the AMR-only zoom on slide 5.
Footers renumbered.

Co-Authored-By: Claude Opus 4.7 (1M context) <noreply@anthropic.com>
Claude-Session: https://claude.ai/code/session_01Fbouf9yKVWMvU7uqqi6hid
</commit_message>
<xml_diff>
--- a/slides/thesis_committee_slides.pptx
+++ b/slides/thesis_committee_slides.pptx
@@ -11,6 +11,7 @@
     <p:sldId id="259" r:id="rId11"/>
     <p:sldId id="260" r:id="rId12"/>
     <p:sldId id="261" r:id="rId13"/>
+    <p:sldId id="262" r:id="rId14"/>
   </p:sldIdLst>
   <p:sldSz cx="12191695" cy="6858000" type="screen4x3"/>
   <p:notesSz cx="6858000" cy="9144000"/>
@@ -717,7 +718,7 @@
           <a:lstStyle/>
           <a:p>
             <a:r>
-              <a:t>This is the headline result. On the Mexican-like cohort (NATMXB track, blue), adding 25 MXB samples to the HGDP baseline lifts NAT recall from 0.931 to 0.942. Adding 50 gets the same benefit (0.942) — 25 is enough. On the Brazilian-like cohort (NAT track, red), the picture flips: the MXB-augmented panel actually LOSES ~2% NAT recall because Brazilian NAT ancestry is closer to Amazonian sources than to Mexican; PEL (Peru) is the best panel there. The homogeneous-only NAT_HOMOG panel matches HGDPMXB on the Mexican cohort while being donor-safe. Punchline for the committee: there is no single best panel — the answer depends on the ancestry composition of the cohort being called.</a:t>
+              <a:t>Overview slide before we zoom in. Three ancestries side by side, same panels, same y-scale. EUR and AFR sit near ceiling regardless of which AMR reference we pick — those calls are easy because the EUR and AFR reference pools are already large and diverse. AMR is the ancestry that moves: ~3% swing across panel choice on the Mexican-like cohort. Motivates zooming in on AMR in the next slide.</a:t>
             </a:r>
           </a:p>
         </p:txBody>
@@ -787,7 +788,7 @@
           <a:lstStyle/>
           <a:p>
             <a:r>
-              <a:t>Complementary result. Same reference panels, but the admixed cohort's haplotypes were down-sampled to the ~385k autosomal Illumina GSA v3 positions before calling. NAT recall drops by only ~0.7-1.2% across panels — the panel ranking is preserved and the direction of every effect matches WGS. This matters because our REDIAL/COG cohorts are chip-genotyped, not WGS — so the WGS result generalizes. Michigan/1KG imputation is the post-committee validation step; today we can already recommend HGDPMXB (+25 MXB) for the Mexican-Latino LAI pipeline. NAT_HOMOG is a donor-safe backup that performs equivalently.</a:t>
+              <a:t>This is the headline result. On the Mexican-like cohort (NATMXB track, blue), adding 25 MXB samples to the HGDP baseline lifts NAT recall from 0.931 to 0.942. Adding 50 gets the same benefit (0.942) — 25 is enough. On the Brazilian-like cohort (NAT track, red), the picture flips: the MXB-augmented panel actually LOSES ~2% NAT recall because Brazilian NAT ancestry is closer to Amazonian sources than to Mexican; PEL (Peru) is the best panel there. The homogeneous-only NAT_HOMOG panel matches HGDPMXB on the Mexican cohort while being donor-safe. Punchline for the committee: there is no single best panel — the answer depends on the ancestry composition of the cohort being called.</a:t>
             </a:r>
           </a:p>
         </p:txBody>
@@ -813,6 +814,76 @@
 </file>
 
 <file path=ppt/notesSlides/notesSlide6.xml><?xml version="1.0" encoding="utf-8"?>
+<p:notes xmlns:a="http://schemas.openxmlformats.org/drawingml/2006/main" xmlns:p="http://schemas.openxmlformats.org/presentationml/2006/main" xmlns:r="http://schemas.openxmlformats.org/officeDocument/2006/relationships">
+  <p:cSld>
+    <p:spTree>
+      <p:nvGrpSpPr>
+        <p:cNvPr id="1" name=""/>
+        <p:cNvGrpSpPr/>
+        <p:nvPr/>
+      </p:nvGrpSpPr>
+      <p:grpSpPr>
+        <a:xfrm>
+          <a:off x="0" y="0"/>
+          <a:ext cx="0" cy="0"/>
+          <a:chOff x="0" y="0"/>
+          <a:chExt cx="0" cy="0"/>
+        </a:xfrm>
+      </p:grpSpPr>
+      <p:sp>
+        <p:nvSpPr>
+          <p:cNvPr id="2" name="Slide Image Placeholder 1"/>
+          <p:cNvSpPr>
+            <a:spLocks noGrp="1"/>
+          </p:cNvSpPr>
+          <p:nvPr>
+            <p:ph type="sldImg" idx="2"/>
+          </p:nvPr>
+        </p:nvSpPr>
+        <p:spPr/>
+      </p:sp>
+      <p:sp>
+        <p:nvSpPr>
+          <p:cNvPr id="3" name="Notes Placeholder 2"/>
+          <p:cNvSpPr>
+            <a:spLocks noGrp="1"/>
+          </p:cNvSpPr>
+          <p:nvPr>
+            <p:ph type="body" idx="3" sz="quarter"/>
+          </p:nvPr>
+        </p:nvSpPr>
+        <p:spPr/>
+        <p:txBody>
+          <a:bodyPr/>
+          <a:lstStyle/>
+          <a:p>
+            <a:r>
+              <a:t>Complementary result. Same reference panels, but the admixed cohort's haplotypes were down-sampled to the ~385k autosomal Illumina GSA v3 positions before calling. NAT recall drops by only ~0.7-1.2% across panels — the panel ranking is preserved and the direction of every effect matches WGS. This matters because our REDIAL/COG cohorts are chip-genotyped, not WGS — so the WGS result generalizes. Michigan/1KG imputation is the post-committee validation step; today we can already recommend HGDPMXB (+25 MXB) for the Mexican-Latino LAI pipeline. NAT_HOMOG is a donor-safe backup that performs equivalently.</a:t>
+            </a:r>
+          </a:p>
+        </p:txBody>
+      </p:sp>
+      <p:sp>
+        <p:nvSpPr>
+          <p:cNvPr id="4" name="Slide Number Placeholder 3"/>
+          <p:cNvSpPr>
+            <a:spLocks noGrp="1"/>
+          </p:cNvSpPr>
+          <p:nvPr>
+            <p:ph type="sldNum" idx="5" sz="quarter"/>
+          </p:nvPr>
+        </p:nvSpPr>
+        <p:spPr/>
+      </p:sp>
+    </p:spTree>
+  </p:cSld>
+  <p:clrMapOvr>
+    <a:masterClrMapping/>
+  </p:clrMapOvr>
+</p:notes>
+</file>
+
+<file path=ppt/notesSlides/notesSlide7.xml><?xml version="1.0" encoding="utf-8"?>
 <p:notes xmlns:a="http://schemas.openxmlformats.org/drawingml/2006/main" xmlns:p="http://schemas.openxmlformats.org/presentationml/2006/main" xmlns:r="http://schemas.openxmlformats.org/officeDocument/2006/relationships">
   <p:cSld>
     <p:spTree>
@@ -4200,7 +4271,7 @@
         <p:spPr>
           <a:xfrm>
             <a:off x="365760" y="1508760"/>
-            <a:ext cx="11430000" cy="4392192"/>
+            <a:ext cx="11430000" cy="5182945"/>
           </a:xfrm>
           <a:prstGeom prst="rect">
             <a:avLst/>
@@ -4304,7 +4375,7 @@
                   <a:srgbClr val="666666"/>
                 </a:solidFill>
               </a:rPr>
-              <a:t>2 / 6</a:t>
+              <a:t>2 / 7</a:t>
             </a:r>
           </a:p>
         </p:txBody>
@@ -5506,7 +5577,7 @@
                   <a:srgbClr val="666666"/>
                 </a:solidFill>
               </a:rPr>
-              <a:t>3 / 6</a:t>
+              <a:t>3 / 7</a:t>
             </a:r>
           </a:p>
         </p:txBody>
@@ -5557,7 +5628,7 @@
                   <a:srgbClr val="0E2841"/>
                 </a:solidFill>
               </a:rPr>
-              <a:t>Best reference panel depends on the target cohort's composition.</a:t>
+              <a:t>Panel choice moves AMR recall by ~3%; EUR and AFR sit near ceiling.</a:t>
             </a:r>
           </a:p>
         </p:txBody>
@@ -5591,14 +5662,14 @@
                   <a:srgbClr val="666666"/>
                 </a:solidFill>
               </a:rPr>
-              <a:t>Weighted NAT-ancestry recall, WGS density, chr20-22 pilot</a:t>
+              <a:t>Weighted per-hap recall by ancestry, WGS density, chr20-22 pilot</a:t>
             </a:r>
           </a:p>
         </p:txBody>
       </p:sp>
       <p:pic>
         <p:nvPicPr>
-          <p:cNvPr id="4" name="Picture 3" descr="fig_wgs_panels.png"/>
+          <p:cNvPr id="4" name="Picture 3" descr="fig_wgs_all_ancestry.png"/>
           <p:cNvPicPr>
             <a:picLocks noChangeAspect="1"/>
           </p:cNvPicPr>
@@ -5612,8 +5683,8 @@
         </p:blipFill>
         <p:spPr>
           <a:xfrm>
-            <a:off x="502920" y="1508760"/>
-            <a:ext cx="7498079" cy="3599078"/>
+            <a:off x="502920" y="1417320"/>
+            <a:ext cx="11155680" cy="5492027"/>
           </a:xfrm>
           <a:prstGeom prst="rect">
             <a:avLst/>
@@ -5628,8 +5699,8 @@
         </p:nvSpPr>
         <p:spPr>
           <a:xfrm>
-            <a:off x="8275320" y="1600200"/>
-            <a:ext cx="3566160" cy="365760"/>
+            <a:off x="502920" y="6172200"/>
+            <a:ext cx="11155680" cy="320040"/>
           </a:xfrm>
           <a:prstGeom prst="rect">
             <a:avLst/>
@@ -5644,12 +5715,12 @@
           <a:p>
             <a:pPr algn="l"/>
             <a:r>
-              <a:rPr sz="1300" i="0" b="1">
-                <a:solidFill>
-                  <a:srgbClr val="0E2841"/>
-                </a:solidFill>
-              </a:rPr>
-              <a:t>Takeaways</a:t>
+              <a:rPr sz="1200" i="1" b="0">
+                <a:solidFill>
+                  <a:srgbClr val="1A1A1A"/>
+                </a:solidFill>
+              </a:rPr>
+              <a:t>→  AMR is where reference-panel choice actually matters — so the rest of the deck focuses on AMR recall.</a:t>
             </a:r>
           </a:p>
         </p:txBody>
@@ -5662,8 +5733,8 @@
         </p:nvSpPr>
         <p:spPr>
           <a:xfrm>
-            <a:off x="8275320" y="1965960"/>
-            <a:ext cx="3611880" cy="4023360"/>
+            <a:off x="502920" y="6537960"/>
+            <a:ext cx="7315200" cy="274320"/>
           </a:xfrm>
           <a:prstGeom prst="rect">
             <a:avLst/>
@@ -5678,128 +5749,12 @@
           <a:p>
             <a:pPr algn="l"/>
             <a:r>
-              <a:rPr sz="1050" i="0" b="0">
-                <a:solidFill>
-                  <a:srgbClr val="1A1A1A"/>
-                </a:solidFill>
-              </a:rPr>
-              <a:t>For a Mexican-like cohort (blue bars):</a:t>
-            </a:r>
-          </a:p>
-          <a:p>
-            <a:pPr algn="l"/>
-            <a:r>
-              <a:rPr sz="1050" i="0" b="0">
-                <a:solidFill>
-                  <a:srgbClr val="1A1A1A"/>
-                </a:solidFill>
-              </a:rPr>
-              <a:t>•  Adding 25 MXB samples</a:t>
-            </a:r>
-          </a:p>
-          <a:p>
-            <a:pPr algn="l"/>
-            <a:r>
-              <a:rPr sz="1050" i="0" b="0">
-                <a:solidFill>
-                  <a:srgbClr val="1A1A1A"/>
-                </a:solidFill>
-              </a:rPr>
-              <a:t>    lifts NAT recall  0.931 → 0.942</a:t>
-            </a:r>
-          </a:p>
-          <a:p>
-            <a:pPr algn="l"/>
-          </a:p>
-          <a:p>
-            <a:pPr algn="l"/>
-            <a:r>
-              <a:rPr sz="1050" i="0" b="0">
-                <a:solidFill>
-                  <a:srgbClr val="1A1A1A"/>
-                </a:solidFill>
-              </a:rPr>
-              <a:t>For a Brazilian-like cohort (red bars):</a:t>
-            </a:r>
-          </a:p>
-          <a:p>
-            <a:pPr algn="l"/>
-            <a:r>
-              <a:rPr sz="1050" i="0" b="0">
-                <a:solidFill>
-                  <a:srgbClr val="1A1A1A"/>
-                </a:solidFill>
-              </a:rPr>
-              <a:t>•  PEL (Peru) panel wins on NAT</a:t>
-            </a:r>
-          </a:p>
-          <a:p>
-            <a:pPr algn="l"/>
-            <a:r>
-              <a:rPr sz="1050" i="0" b="0">
-                <a:solidFill>
-                  <a:srgbClr val="1A1A1A"/>
-                </a:solidFill>
-              </a:rPr>
-              <a:t>    HGDPMXB actually loses ~2%</a:t>
-            </a:r>
-          </a:p>
-          <a:p>
-            <a:pPr algn="l"/>
-            <a:r>
-              <a:rPr sz="1050" i="0" b="0">
-                <a:solidFill>
-                  <a:srgbClr val="1A1A1A"/>
-                </a:solidFill>
-              </a:rPr>
-              <a:t>•  Adding non-Mexican ancestry</a:t>
-            </a:r>
-          </a:p>
-          <a:p>
-            <a:pPr algn="l"/>
-            <a:r>
-              <a:rPr sz="1050" i="0" b="0">
-                <a:solidFill>
-                  <a:srgbClr val="1A1A1A"/>
-                </a:solidFill>
-              </a:rPr>
-              <a:t>    to a Mexican reference hurts</a:t>
-            </a:r>
-          </a:p>
-          <a:p>
-            <a:pPr algn="l"/>
-          </a:p>
-          <a:p>
-            <a:pPr algn="l"/>
-            <a:r>
-              <a:rPr sz="1050" i="0" b="0">
-                <a:solidFill>
-                  <a:srgbClr val="1A1A1A"/>
-                </a:solidFill>
-              </a:rPr>
-              <a:t>→  Panel-choice must match the</a:t>
-            </a:r>
-          </a:p>
-          <a:p>
-            <a:pPr algn="l"/>
-            <a:r>
-              <a:rPr sz="1050" i="0" b="0">
-                <a:solidFill>
-                  <a:srgbClr val="1A1A1A"/>
-                </a:solidFill>
-              </a:rPr>
-              <a:t>     target cohort, not the largest</a:t>
-            </a:r>
-          </a:p>
-          <a:p>
-            <a:pPr algn="l"/>
-            <a:r>
-              <a:rPr sz="1050" i="0" b="0">
-                <a:solidFill>
-                  <a:srgbClr val="1A1A1A"/>
-                </a:solidFill>
-              </a:rPr>
-              <a:t>     available sample source.</a:t>
+              <a:rPr sz="900" i="0" b="0">
+                <a:solidFill>
+                  <a:srgbClr val="666666"/>
+                </a:solidFill>
+              </a:rPr>
+              <a:t>Christina Magyar  ·  Thesis committee, Aug 2026  ·  Result overview</a:t>
             </a:r>
           </a:p>
         </p:txBody>
@@ -5812,8 +5767,8 @@
         </p:nvSpPr>
         <p:spPr>
           <a:xfrm>
-            <a:off x="502920" y="6537960"/>
-            <a:ext cx="7315200" cy="274320"/>
+            <a:off x="11338560" y="6537960"/>
+            <a:ext cx="548640" cy="274320"/>
           </a:xfrm>
           <a:prstGeom prst="rect">
             <a:avLst/>
@@ -5826,48 +5781,14 @@
           </a:bodyPr>
           <a:lstStyle/>
           <a:p>
-            <a:pPr algn="l"/>
+            <a:pPr algn="r"/>
             <a:r>
               <a:rPr sz="900" i="0" b="0">
                 <a:solidFill>
                   <a:srgbClr val="666666"/>
                 </a:solidFill>
               </a:rPr>
-              <a:t>Christina Magyar  ·  Thesis committee, Aug 2026  ·  Result 1 · WGS</a:t>
-            </a:r>
-          </a:p>
-        </p:txBody>
-      </p:sp>
-      <p:sp>
-        <p:nvSpPr>
-          <p:cNvPr id="8" name="TextBox 7"/>
-          <p:cNvSpPr txBox="1"/>
-          <p:nvPr/>
-        </p:nvSpPr>
-        <p:spPr>
-          <a:xfrm>
-            <a:off x="11338560" y="6537960"/>
-            <a:ext cx="548640" cy="274320"/>
-          </a:xfrm>
-          <a:prstGeom prst="rect">
-            <a:avLst/>
-          </a:prstGeom>
-          <a:noFill/>
-        </p:spPr>
-        <p:txBody>
-          <a:bodyPr wrap="square" lIns="0" rIns="0" tIns="0" bIns="0">
-            <a:spAutoFit/>
-          </a:bodyPr>
-          <a:lstStyle/>
-          <a:p>
-            <a:pPr algn="r"/>
-            <a:r>
-              <a:rPr sz="900" i="0" b="0">
-                <a:solidFill>
-                  <a:srgbClr val="666666"/>
-                </a:solidFill>
-              </a:rPr>
-              <a:t>4 / 6</a:t>
+              <a:t>4 / 7</a:t>
             </a:r>
           </a:p>
         </p:txBody>
@@ -5918,7 +5839,7 @@
                   <a:srgbClr val="0E2841"/>
                 </a:solidFill>
               </a:rPr>
-              <a:t>Chip-density LAI holds within ~1% of WGS on a Mexican-like cohort.</a:t>
+              <a:t>Best reference panel depends on the target cohort's composition.</a:t>
             </a:r>
           </a:p>
         </p:txBody>
@@ -5952,14 +5873,14 @@
                   <a:srgbClr val="666666"/>
                 </a:solidFill>
               </a:rPr>
-              <a:t>Illumina GSA v3 chip vs full WGS density, same reference panels</a:t>
+              <a:t>Weighted NAT-ancestry recall, WGS density, chr20-22 pilot</a:t>
             </a:r>
           </a:p>
         </p:txBody>
       </p:sp>
       <p:pic>
         <p:nvPicPr>
-          <p:cNvPr id="4" name="Picture 3" descr="fig_chip_vs_wgs.png"/>
+          <p:cNvPr id="4" name="Picture 3" descr="fig_wgs_panels.png"/>
           <p:cNvPicPr>
             <a:picLocks noChangeAspect="1"/>
           </p:cNvPicPr>
@@ -5974,7 +5895,7 @@
         <p:spPr>
           <a:xfrm>
             <a:off x="502920" y="1508760"/>
-            <a:ext cx="7680960" cy="3609547"/>
+            <a:ext cx="7498079" cy="3599078"/>
           </a:xfrm>
           <a:prstGeom prst="rect">
             <a:avLst/>
@@ -5989,7 +5910,7 @@
         </p:nvSpPr>
         <p:spPr>
           <a:xfrm>
-            <a:off x="8366760" y="1600200"/>
+            <a:off x="8275320" y="1600200"/>
             <a:ext cx="3566160" cy="365760"/>
           </a:xfrm>
           <a:prstGeom prst="rect">
@@ -6010,7 +5931,7 @@
                   <a:srgbClr val="0E2841"/>
                 </a:solidFill>
               </a:rPr>
-              <a:t>Implications for GWAS</a:t>
+              <a:t>Takeaways</a:t>
             </a:r>
           </a:p>
         </p:txBody>
@@ -6023,7 +5944,7 @@
         </p:nvSpPr>
         <p:spPr>
           <a:xfrm>
-            <a:off x="8366760" y="1965960"/>
+            <a:off x="8275320" y="1965960"/>
             <a:ext cx="3611880" cy="4023360"/>
           </a:xfrm>
           <a:prstGeom prst="rect">
@@ -6044,7 +5965,7 @@
                   <a:srgbClr val="1A1A1A"/>
                 </a:solidFill>
               </a:rPr>
-              <a:t>•  REDIAL / COG cohorts are</a:t>
+              <a:t>For a Mexican-like cohort (blue bars):</a:t>
             </a:r>
           </a:p>
           <a:p>
@@ -6055,7 +5976,7 @@
                   <a:srgbClr val="1A1A1A"/>
                 </a:solidFill>
               </a:rPr>
-              <a:t>    genotyped on chip, not WGS —</a:t>
+              <a:t>•  Adding 25 MXB samples</a:t>
             </a:r>
           </a:p>
           <a:p>
@@ -6066,22 +5987,33 @@
                   <a:srgbClr val="1A1A1A"/>
                 </a:solidFill>
               </a:rPr>
-              <a:t>    LAI accuracy holds if we</a:t>
+              <a:t>    lifts NAT recall  0.931 → 0.942</a:t>
             </a:r>
           </a:p>
           <a:p>
             <a:pPr algn="l"/>
+          </a:p>
+          <a:p>
+            <a:pPr algn="l"/>
             <a:r>
               <a:rPr sz="1050" i="0" b="0">
                 <a:solidFill>
                   <a:srgbClr val="1A1A1A"/>
                 </a:solidFill>
               </a:rPr>
-              <a:t>    use the MXB-augmented panel</a:t>
+              <a:t>For a Brazilian-like cohort (red bars):</a:t>
             </a:r>
           </a:p>
           <a:p>
             <a:pPr algn="l"/>
+            <a:r>
+              <a:rPr sz="1050" i="0" b="0">
+                <a:solidFill>
+                  <a:srgbClr val="1A1A1A"/>
+                </a:solidFill>
+              </a:rPr>
+              <a:t>•  PEL (Peru) panel wins on NAT</a:t>
+            </a:r>
           </a:p>
           <a:p>
             <a:pPr algn="l"/>
@@ -6091,7 +6023,7 @@
                   <a:srgbClr val="1A1A1A"/>
                 </a:solidFill>
               </a:rPr>
-              <a:t>•  Chip → TOPMed imputation is</a:t>
+              <a:t>    HGDPMXB actually loses ~2%</a:t>
             </a:r>
           </a:p>
           <a:p>
@@ -6102,7 +6034,7 @@
                   <a:srgbClr val="1A1A1A"/>
                 </a:solidFill>
               </a:rPr>
-              <a:t>    the next validation step</a:t>
+              <a:t>•  Adding non-Mexican ancestry</a:t>
             </a:r>
           </a:p>
           <a:p>
@@ -6113,7 +6045,7 @@
                   <a:srgbClr val="1A1A1A"/>
                 </a:solidFill>
               </a:rPr>
-              <a:t>    (Michigan / 1KG post-meeting)</a:t>
+              <a:t>    to a Mexican reference hurts</a:t>
             </a:r>
           </a:p>
           <a:p>
@@ -6127,7 +6059,7 @@
                   <a:srgbClr val="1A1A1A"/>
                 </a:solidFill>
               </a:rPr>
-              <a:t>•  Panel ranking preserved</a:t>
+              <a:t>→  Panel-choice must match the</a:t>
             </a:r>
           </a:p>
           <a:p>
@@ -6138,7 +6070,7 @@
                   <a:srgbClr val="1A1A1A"/>
                 </a:solidFill>
               </a:rPr>
-              <a:t>    across densities:</a:t>
+              <a:t>     target cohort, not the largest</a:t>
             </a:r>
           </a:p>
           <a:p>
@@ -6149,32 +6081,7 @@
                   <a:srgbClr val="1A1A1A"/>
                 </a:solidFill>
               </a:rPr>
-              <a:t>     HGDPMXB &gt; HGDP &gt; PEL_EAS</a:t>
-            </a:r>
-          </a:p>
-          <a:p>
-            <a:pPr algn="l"/>
-          </a:p>
-          <a:p>
-            <a:pPr algn="l"/>
-            <a:r>
-              <a:rPr sz="1050" i="0" b="0">
-                <a:solidFill>
-                  <a:srgbClr val="1A1A1A"/>
-                </a:solidFill>
-              </a:rPr>
-              <a:t>•  Recommend HGDPMXB for the</a:t>
-            </a:r>
-          </a:p>
-          <a:p>
-            <a:pPr algn="l"/>
-            <a:r>
-              <a:rPr sz="1050" i="0" b="0">
-                <a:solidFill>
-                  <a:srgbClr val="1A1A1A"/>
-                </a:solidFill>
-              </a:rPr>
-              <a:t>    Mexican-Latino GWAS pipeline</a:t>
+              <a:t>     available sample source.</a:t>
             </a:r>
           </a:p>
         </p:txBody>
@@ -6208,7 +6115,7 @@
                   <a:srgbClr val="666666"/>
                 </a:solidFill>
               </a:rPr>
-              <a:t>Christina Magyar  ·  Thesis committee, Aug 2026  ·  Result 2 · Chip</a:t>
+              <a:t>Christina Magyar  ·  Thesis committee, Aug 2026  ·  Result · AMR zoom</a:t>
             </a:r>
           </a:p>
         </p:txBody>
@@ -6242,7 +6149,7 @@
                   <a:srgbClr val="666666"/>
                 </a:solidFill>
               </a:rPr>
-              <a:t>5 / 6</a:t>
+              <a:t>5 / 7</a:t>
             </a:r>
           </a:p>
         </p:txBody>
@@ -6293,6 +6200,381 @@
                   <a:srgbClr val="0E2841"/>
                 </a:solidFill>
               </a:rPr>
+              <a:t>Chip-density LAI holds within ~1% of WGS on a Mexican-like cohort.</a:t>
+            </a:r>
+          </a:p>
+        </p:txBody>
+      </p:sp>
+      <p:sp>
+        <p:nvSpPr>
+          <p:cNvPr id="3" name="TextBox 2"/>
+          <p:cNvSpPr txBox="1"/>
+          <p:nvPr/>
+        </p:nvSpPr>
+        <p:spPr>
+          <a:xfrm>
+            <a:off x="502920" y="1051560"/>
+            <a:ext cx="11155680" cy="365760"/>
+          </a:xfrm>
+          <a:prstGeom prst="rect">
+            <a:avLst/>
+          </a:prstGeom>
+          <a:noFill/>
+        </p:spPr>
+        <p:txBody>
+          <a:bodyPr wrap="square" lIns="0" rIns="0" tIns="0" bIns="0">
+            <a:spAutoFit/>
+          </a:bodyPr>
+          <a:lstStyle/>
+          <a:p>
+            <a:pPr algn="l"/>
+            <a:r>
+              <a:rPr sz="1200" i="1" b="0">
+                <a:solidFill>
+                  <a:srgbClr val="666666"/>
+                </a:solidFill>
+              </a:rPr>
+              <a:t>Illumina GSA v3 chip vs full WGS density, same reference panels</a:t>
+            </a:r>
+          </a:p>
+        </p:txBody>
+      </p:sp>
+      <p:pic>
+        <p:nvPicPr>
+          <p:cNvPr id="4" name="Picture 3" descr="fig_chip_vs_wgs.png"/>
+          <p:cNvPicPr>
+            <a:picLocks noChangeAspect="1"/>
+          </p:cNvPicPr>
+          <p:nvPr/>
+        </p:nvPicPr>
+        <p:blipFill>
+          <a:blip r:embed="rId2"/>
+          <a:stretch>
+            <a:fillRect/>
+          </a:stretch>
+        </p:blipFill>
+        <p:spPr>
+          <a:xfrm>
+            <a:off x="502920" y="1508760"/>
+            <a:ext cx="7680960" cy="3609547"/>
+          </a:xfrm>
+          <a:prstGeom prst="rect">
+            <a:avLst/>
+          </a:prstGeom>
+        </p:spPr>
+      </p:pic>
+      <p:sp>
+        <p:nvSpPr>
+          <p:cNvPr id="5" name="TextBox 4"/>
+          <p:cNvSpPr txBox="1"/>
+          <p:nvPr/>
+        </p:nvSpPr>
+        <p:spPr>
+          <a:xfrm>
+            <a:off x="8366760" y="1600200"/>
+            <a:ext cx="3566160" cy="365760"/>
+          </a:xfrm>
+          <a:prstGeom prst="rect">
+            <a:avLst/>
+          </a:prstGeom>
+          <a:noFill/>
+        </p:spPr>
+        <p:txBody>
+          <a:bodyPr wrap="square" lIns="0" rIns="0" tIns="0" bIns="0">
+            <a:spAutoFit/>
+          </a:bodyPr>
+          <a:lstStyle/>
+          <a:p>
+            <a:pPr algn="l"/>
+            <a:r>
+              <a:rPr sz="1300" i="0" b="1">
+                <a:solidFill>
+                  <a:srgbClr val="0E2841"/>
+                </a:solidFill>
+              </a:rPr>
+              <a:t>Implications for GWAS</a:t>
+            </a:r>
+          </a:p>
+        </p:txBody>
+      </p:sp>
+      <p:sp>
+        <p:nvSpPr>
+          <p:cNvPr id="6" name="TextBox 5"/>
+          <p:cNvSpPr txBox="1"/>
+          <p:nvPr/>
+        </p:nvSpPr>
+        <p:spPr>
+          <a:xfrm>
+            <a:off x="8366760" y="1965960"/>
+            <a:ext cx="3611880" cy="4023360"/>
+          </a:xfrm>
+          <a:prstGeom prst="rect">
+            <a:avLst/>
+          </a:prstGeom>
+          <a:noFill/>
+        </p:spPr>
+        <p:txBody>
+          <a:bodyPr wrap="square" lIns="0" rIns="0" tIns="0" bIns="0">
+            <a:spAutoFit/>
+          </a:bodyPr>
+          <a:lstStyle/>
+          <a:p>
+            <a:pPr algn="l"/>
+            <a:r>
+              <a:rPr sz="1050" i="0" b="0">
+                <a:solidFill>
+                  <a:srgbClr val="1A1A1A"/>
+                </a:solidFill>
+              </a:rPr>
+              <a:t>•  REDIAL / COG cohorts are</a:t>
+            </a:r>
+          </a:p>
+          <a:p>
+            <a:pPr algn="l"/>
+            <a:r>
+              <a:rPr sz="1050" i="0" b="0">
+                <a:solidFill>
+                  <a:srgbClr val="1A1A1A"/>
+                </a:solidFill>
+              </a:rPr>
+              <a:t>    genotyped on chip, not WGS —</a:t>
+            </a:r>
+          </a:p>
+          <a:p>
+            <a:pPr algn="l"/>
+            <a:r>
+              <a:rPr sz="1050" i="0" b="0">
+                <a:solidFill>
+                  <a:srgbClr val="1A1A1A"/>
+                </a:solidFill>
+              </a:rPr>
+              <a:t>    LAI accuracy holds if we</a:t>
+            </a:r>
+          </a:p>
+          <a:p>
+            <a:pPr algn="l"/>
+            <a:r>
+              <a:rPr sz="1050" i="0" b="0">
+                <a:solidFill>
+                  <a:srgbClr val="1A1A1A"/>
+                </a:solidFill>
+              </a:rPr>
+              <a:t>    use the MXB-augmented panel</a:t>
+            </a:r>
+          </a:p>
+          <a:p>
+            <a:pPr algn="l"/>
+          </a:p>
+          <a:p>
+            <a:pPr algn="l"/>
+            <a:r>
+              <a:rPr sz="1050" i="0" b="0">
+                <a:solidFill>
+                  <a:srgbClr val="1A1A1A"/>
+                </a:solidFill>
+              </a:rPr>
+              <a:t>•  Chip → TOPMed imputation is</a:t>
+            </a:r>
+          </a:p>
+          <a:p>
+            <a:pPr algn="l"/>
+            <a:r>
+              <a:rPr sz="1050" i="0" b="0">
+                <a:solidFill>
+                  <a:srgbClr val="1A1A1A"/>
+                </a:solidFill>
+              </a:rPr>
+              <a:t>    the next validation step</a:t>
+            </a:r>
+          </a:p>
+          <a:p>
+            <a:pPr algn="l"/>
+            <a:r>
+              <a:rPr sz="1050" i="0" b="0">
+                <a:solidFill>
+                  <a:srgbClr val="1A1A1A"/>
+                </a:solidFill>
+              </a:rPr>
+              <a:t>    (Michigan / 1KG post-meeting)</a:t>
+            </a:r>
+          </a:p>
+          <a:p>
+            <a:pPr algn="l"/>
+          </a:p>
+          <a:p>
+            <a:pPr algn="l"/>
+            <a:r>
+              <a:rPr sz="1050" i="0" b="0">
+                <a:solidFill>
+                  <a:srgbClr val="1A1A1A"/>
+                </a:solidFill>
+              </a:rPr>
+              <a:t>•  Panel ranking preserved</a:t>
+            </a:r>
+          </a:p>
+          <a:p>
+            <a:pPr algn="l"/>
+            <a:r>
+              <a:rPr sz="1050" i="0" b="0">
+                <a:solidFill>
+                  <a:srgbClr val="1A1A1A"/>
+                </a:solidFill>
+              </a:rPr>
+              <a:t>    across densities:</a:t>
+            </a:r>
+          </a:p>
+          <a:p>
+            <a:pPr algn="l"/>
+            <a:r>
+              <a:rPr sz="1050" i="0" b="0">
+                <a:solidFill>
+                  <a:srgbClr val="1A1A1A"/>
+                </a:solidFill>
+              </a:rPr>
+              <a:t>     HGDPMXB &gt; HGDP &gt; PEL_EAS</a:t>
+            </a:r>
+          </a:p>
+          <a:p>
+            <a:pPr algn="l"/>
+          </a:p>
+          <a:p>
+            <a:pPr algn="l"/>
+            <a:r>
+              <a:rPr sz="1050" i="0" b="0">
+                <a:solidFill>
+                  <a:srgbClr val="1A1A1A"/>
+                </a:solidFill>
+              </a:rPr>
+              <a:t>•  Recommend HGDPMXB for the</a:t>
+            </a:r>
+          </a:p>
+          <a:p>
+            <a:pPr algn="l"/>
+            <a:r>
+              <a:rPr sz="1050" i="0" b="0">
+                <a:solidFill>
+                  <a:srgbClr val="1A1A1A"/>
+                </a:solidFill>
+              </a:rPr>
+              <a:t>    Mexican-Latino GWAS pipeline</a:t>
+            </a:r>
+          </a:p>
+        </p:txBody>
+      </p:sp>
+      <p:sp>
+        <p:nvSpPr>
+          <p:cNvPr id="7" name="TextBox 6"/>
+          <p:cNvSpPr txBox="1"/>
+          <p:nvPr/>
+        </p:nvSpPr>
+        <p:spPr>
+          <a:xfrm>
+            <a:off x="502920" y="6537960"/>
+            <a:ext cx="7315200" cy="274320"/>
+          </a:xfrm>
+          <a:prstGeom prst="rect">
+            <a:avLst/>
+          </a:prstGeom>
+          <a:noFill/>
+        </p:spPr>
+        <p:txBody>
+          <a:bodyPr wrap="square" lIns="0" rIns="0" tIns="0" bIns="0">
+            <a:spAutoFit/>
+          </a:bodyPr>
+          <a:lstStyle/>
+          <a:p>
+            <a:pPr algn="l"/>
+            <a:r>
+              <a:rPr sz="900" i="0" b="0">
+                <a:solidFill>
+                  <a:srgbClr val="666666"/>
+                </a:solidFill>
+              </a:rPr>
+              <a:t>Christina Magyar  ·  Thesis committee, Aug 2026  ·  Result · Chip</a:t>
+            </a:r>
+          </a:p>
+        </p:txBody>
+      </p:sp>
+      <p:sp>
+        <p:nvSpPr>
+          <p:cNvPr id="8" name="TextBox 7"/>
+          <p:cNvSpPr txBox="1"/>
+          <p:nvPr/>
+        </p:nvSpPr>
+        <p:spPr>
+          <a:xfrm>
+            <a:off x="11338560" y="6537960"/>
+            <a:ext cx="548640" cy="274320"/>
+          </a:xfrm>
+          <a:prstGeom prst="rect">
+            <a:avLst/>
+          </a:prstGeom>
+          <a:noFill/>
+        </p:spPr>
+        <p:txBody>
+          <a:bodyPr wrap="square" lIns="0" rIns="0" tIns="0" bIns="0">
+            <a:spAutoFit/>
+          </a:bodyPr>
+          <a:lstStyle/>
+          <a:p>
+            <a:pPr algn="r"/>
+            <a:r>
+              <a:rPr sz="900" i="0" b="0">
+                <a:solidFill>
+                  <a:srgbClr val="666666"/>
+                </a:solidFill>
+              </a:rPr>
+              <a:t>6 / 7</a:t>
+            </a:r>
+          </a:p>
+        </p:txBody>
+      </p:sp>
+    </p:spTree>
+  </p:cSld>
+  <p:clrMapOvr>
+    <a:masterClrMapping/>
+  </p:clrMapOvr>
+</p:sld>
+</file>
+
+<file path=ppt/slides/slide7.xml><?xml version="1.0" encoding="utf-8"?>
+<p:sld xmlns:a="http://schemas.openxmlformats.org/drawingml/2006/main" xmlns:p="http://schemas.openxmlformats.org/presentationml/2006/main" xmlns:r="http://schemas.openxmlformats.org/officeDocument/2006/relationships">
+  <p:cSld>
+    <p:spTree>
+      <p:nvGrpSpPr>
+        <p:cNvPr id="1" name=""/>
+        <p:cNvGrpSpPr/>
+        <p:nvPr/>
+      </p:nvGrpSpPr>
+      <p:grpSpPr/>
+      <p:sp>
+        <p:nvSpPr>
+          <p:cNvPr id="2" name="TextBox 1"/>
+          <p:cNvSpPr txBox="1"/>
+          <p:nvPr/>
+        </p:nvSpPr>
+        <p:spPr>
+          <a:xfrm>
+            <a:off x="502920" y="292608"/>
+            <a:ext cx="11155680" cy="822960"/>
+          </a:xfrm>
+          <a:prstGeom prst="rect">
+            <a:avLst/>
+          </a:prstGeom>
+          <a:noFill/>
+        </p:spPr>
+        <p:txBody>
+          <a:bodyPr wrap="square">
+            <a:spAutoFit/>
+          </a:bodyPr>
+          <a:lstStyle/>
+          <a:p>
+            <a:r>
+              <a:rPr sz="2400" b="1">
+                <a:solidFill>
+                  <a:srgbClr val="0E2841"/>
+                </a:solidFill>
+              </a:rPr>
               <a:t>8-module Nextflow preprocessing pipeline built; benchmarking underway.</a:t>
             </a:r>
           </a:p>
@@ -6878,7 +7160,7 @@
                   <a:srgbClr val="666666"/>
                 </a:solidFill>
               </a:rPr>
-              <a:t>6 / 6</a:t>
+              <a:t>7 / 7</a:t>
             </a:r>
           </a:p>
         </p:txBody>

</xml_diff>

<commit_message>
slides: metrics cheat sheet in slide 5 notes + publication AMR table
- slides/make_metrics_table.py: renders publication table (AMR only)
  and writes 2 TSVs (AMR compact + all-ancestries full)
- results/tables/publication_table_amr.tsv + publication_table_full.tsv
- slides/tables/publication_table_amr.png (winners bolded in orange)
- slide 5 speaker notes now carry a metrics cheat sheet:
    TP/FP/FN, recall (== sensitivity), precision (== PPV),
    F1 (harmonic mean of P and R, NOT sensitivity+specificity),
    weighted vs unweighted, concordance convention, SE meaning

Co-Authored-By: Claude Opus 4.7 (1M context) <noreply@anthropic.com>
Claude-Session: https://claude.ai/code/session_01Fbouf9yKVWMvU7uqqi6hid
</commit_message>
<xml_diff>
--- a/slides/thesis_committee_slides.pptx
+++ b/slides/thesis_committee_slides.pptx
@@ -788,7 +788,53 @@
           <a:lstStyle/>
           <a:p>
             <a:r>
-              <a:t>This is the headline result. On the Mexican-like cohort (NATMXB track, blue), adding 25 MXB samples to the HGDP baseline lifts NAT recall from 0.931 to 0.942. Adding 50 gets the same benefit (0.942) — 25 is enough. On the Brazilian-like cohort (NAT track, red), the picture flips: the MXB-augmented panel actually LOSES ~2% NAT recall because Brazilian NAT ancestry is closer to Amazonian sources than to Mexican; PEL (Peru) is the best panel there. The homogeneous-only NAT_HOMOG panel matches HGDPMXB on the Mexican cohort while being donor-safe. Punchline for the committee: there is no single best panel — the answer depends on the ancestry composition of the cohort being called.</a:t>
+              <a:t>HEADLINE RESULT. On the Mexican-like cohort (NATMXB track, teal), adding 25 MXB samples to the HGDP baseline lifts NAT recall from 0.931 to 0.942 and F1 from 0.956 to 0.965. Adding 50 gets the same benefit (0.942 / 0.965) — 25 is enough. On the Brazilian-like cohort (NAT track, orange) the recall picture flips: the MXB-augmented panel LOSES ~2-5% NAT recall because Brazilian NAT ancestry is closer to Amazonian sources than Mexican; PEL (Peru) matches or beats HGDP on that cohort. But on F1 the Brazilian penalty softens — precision goes UP when MXB is added because the panel gets stricter about calling AMR, and F1 barely moves. NAT_HOMOG (Q≥0.95 filter) matches HGDPMXB on the Mexican cohort while being donor-safe. Punchline: no single best panel — the winner depends on the cohort's ancestry composition.</a:t>
+            </a:r>
+          </a:p>
+          <a:p/>
+          <a:p>
+            <a:r>
+              <a:t>──────── METRICS CHEAT SHEET ────────</a:t>
+            </a:r>
+          </a:p>
+          <a:p>
+            <a:r>
+              <a:t>• TP / FP / FN: sites where called ancestry matches truth (TP), calls were wrong-class (FP), or truth was this class but we missed (FN). TN is ignored — this is a small-positive-class setting.</a:t>
+            </a:r>
+          </a:p>
+          <a:p>
+            <a:r>
+              <a:t>• Recall = Sensitivity = TPR = TP / (TP + FN). Of all true NAT sites, how many we recovered. Currently plotted on the hero bars.</a:t>
+            </a:r>
+          </a:p>
+          <a:p>
+            <a:r>
+              <a:t>• Precision = PPV = TP / (TP + FP). Of the sites we CALLED NAT, how many were actually NAT. Guards against over-calling.</a:t>
+            </a:r>
+          </a:p>
+          <a:p>
+            <a:r>
+              <a:t>• F1 = 2·P·R / (P + R). Harmonic mean of precision and recall — the class-imbalance-robust summary. NOT the same as balanced accuracy (which uses specificity); F1 ignores TN by design.</a:t>
+            </a:r>
+          </a:p>
+          <a:p>
+            <a:r>
+              <a:t>• Weighted (in these tables): concordance / recall / precision are weighted by (n_haps × n_sites) per chromosome so long chromosomes and larger haplotype counts contribute more.</a:t>
+            </a:r>
+          </a:p>
+          <a:p>
+            <a:r>
+              <a:t>• Concordance in these tables (== weighted_recall in current R impl) is per-site agreement to truth, per ancestry, one-vs-rest.</a:t>
+            </a:r>
+          </a:p>
+          <a:p>
+            <a:r>
+              <a:t>• SE: standard error of the per-chromosome mean (not a bootstrap CI).</a:t>
+            </a:r>
+          </a:p>
+          <a:p>
+            <a:r>
+              <a:t>Publication table with all three metrics is committed to results/tables/publication_table_amr.tsv and rendered to slides/tables/publication_table_amr.png.</a:t>
             </a:r>
           </a:p>
         </p:txBody>

</xml_diff>

<commit_message>
slides: correct HOMOG description in speaker notes
HOMOG is HGDP+1KG+MXB joint-called and Q>=0.95-filtered (i.e., it
INCLUDES MXB samples), not an MXB-free / donor-safe alternative as
prior notes claimed. Corrected wording on slide 5 + pipeline slide.

Co-Authored-By: Claude Opus 4.7 (1M context) <noreply@anthropic.com>
Claude-Session: https://claude.ai/code/session_01Fbouf9yKVWMvU7uqqi6hid
</commit_message>
<xml_diff>
--- a/slides/thesis_committee_slides.pptx
+++ b/slides/thesis_committee_slides.pptx
@@ -1149,7 +1149,7 @@
           <a:lstStyle/>
           <a:p>
             <a:r>
-              <a:t>HEADLINE RESULT. Extended pilot numbers (chr 1-8 + 20-22 for the 4 full-coverage panels; chr20-22 only for HOMOG and PEL_EAS — flagged with *). On the Mexican-like cohort (NATMXB track, teal): +25 MXB lifts NAT recall from 0.954 → 0.958 and F1 from 0.969 → 0.974 (cleanest single winner). On the Brazilian-like cohort (NAT track, orange): +25 MXB costs ~1% NAT recall (0.930 → 0.920) but bumps precision (0.981 → 0.990), so F1 is roughly flat. +50 MXB (HGDPMXB_FULL) costs more recall (0.902) with only marginal F1 benefit — 25 MXB is the sweet spot. PEL matches or beats HGDP on the Brazilian cohort. NAT_HOMOG (Q≥0.95 filter, donor-safe) performs comparably to HGDPMXB in the 3-chr subset we have — worth re-running with full coverage. Punchline: adding MXB is a clear win for a Mexican-cohort GWAS; matched-source reference (PEL for Brazilian) matters more than panel size.</a:t>
+              <a:t>HEADLINE RESULT. Extended pilot numbers (chr 1-8 + 20-22 for the 4 full-coverage panels; chr20-22 only for HOMOG and PEL_EAS — flagged with *). On the Mexican-like cohort (NATMXB track, teal): +25 MXB lifts NAT recall from 0.954 → 0.958 and F1 from 0.969 → 0.974 (cleanest single winner). On the Brazilian-like cohort (NAT track, orange): +25 MXB costs ~1% NAT recall (0.930 → 0.920) but bumps precision (0.981 → 0.990), so F1 is roughly flat. +50 MXB (HGDPMXB_FULL) costs more recall (0.902) with only marginal F1 benefit — 25 MXB is the sweet spot. PEL matches or beats HGDP on the Brazilian cohort. NAT_HOMOG (HGDP + 1KG + MXB jointly filtered to Q≥0.95 by supervised ADMIXTURE — includes MXB samples but excludes admixed individuals) matches HGDPMXB on Mexican-cohort F1 (0.972) with full coverage. Punchline: adding MXB is a clear win for a Mexican-cohort GWAS; matched-source reference (PEL for Brazilian) matters more than panel size; HOMOG is the principled alternative when we want a stricter homogeneity criterion.</a:t>
             </a:r>
           </a:p>
           <a:p/>
@@ -1265,7 +1265,7 @@
           <a:lstStyle/>
           <a:p>
             <a:r>
-              <a:t>Complementary result. Same reference panels, but the admixed cohort's haplotypes were down-sampled to the ~385k autosomal Illumina GSA v3 positions before calling. NAT recall drops by only ~0.7-1.2% across panels — the panel ranking is preserved and the direction of every effect matches WGS. This matters because our REDIAL/COG cohorts are chip-genotyped, not WGS — so the WGS result generalizes. Michigan/1KG imputation is the post-committee validation step; today we can already recommend HGDPMXB (+25 MXB) for the Mexican-Latino LAI pipeline. NAT_HOMOG is a donor-safe backup that performs equivalently.</a:t>
+              <a:t>Complementary result. Same reference panels, but the admixed cohort's haplotypes were down-sampled to the ~385k autosomal Illumina GSA v3 positions before calling. NAT recall drops by only ~0.7-1.2% across panels — the panel ranking is preserved and the direction of every effect matches WGS. This matters because our REDIAL/COG cohorts are chip-genotyped, not WGS — so the WGS result generalizes. Michigan/1KG imputation is the post-committee validation step; today we can already recommend HGDPMXB (+25 MXB) for the Mexican-Latino LAI pipeline. NAT_HOMOG (Q≥0.95 across HGDP+1KG+MXB joint) matches HGDPMXB.</a:t>
             </a:r>
           </a:p>
         </p:txBody>

</xml_diff>